<commit_message>
docs: 培训 PPT 同步 v2.3 — user-journey-flows/uml-pack 替代 ux-flows/ui-wireframes，Mermaid 流程图，新增按需读取规则
</commit_message>
<xml_diff>
--- a/SSOT-开发方法论-培训.pptx
+++ b/SSOT-开发方法论-培训.pptx
@@ -4370,6 +4370,23 @@
                 <a:cs typeface="Calibri" pitchFamily="34" charset="-120"/>
               </a:rPr>
               <a:t>❌ 自动 git commit/push（展示改动等确认）</a:t>
+            </a:r>
+            <a:endParaRPr lang="en-US" sz="1000" dirty="0"/>
+          </a:p>
+          <a:p>
+            <a:pPr indent="0" marL="0">
+              <a:buNone/>
+            </a:pPr>
+            <a:r>
+              <a:rPr lang="en-US" sz="1000" dirty="0">
+                <a:solidFill>
+                  <a:srgbClr val="1E293B"/>
+                </a:solidFill>
+                <a:latin typeface="Calibri" pitchFamily="34" charset="0"/>
+                <a:ea typeface="Calibri" pitchFamily="34" charset="-122"/>
+                <a:cs typeface="Calibri" pitchFamily="34" charset="-120"/>
+              </a:rPr>
+              <a:t>❌ 每次任务全量重读 docs/（按 P0/P1/P2 按需读取）</a:t>
             </a:r>
             <a:endParaRPr lang="en-US" sz="1000" dirty="0"/>
           </a:p>
@@ -11898,7 +11915,7 @@
                 <a:ea typeface="Calibri" pitchFamily="34" charset="-122"/>
                 <a:cs typeface="Calibri" pitchFamily="34" charset="-120"/>
               </a:rPr>
-              <a:t>ux-flows.md</a:t>
+              <a:t>user-journey-flows.md</a:t>
             </a:r>
             <a:endParaRPr lang="en-US" sz="1100" dirty="0"/>
           </a:p>
@@ -11915,7 +11932,7 @@
                 <a:ea typeface="Calibri" pitchFamily="34" charset="-122"/>
                 <a:cs typeface="Calibri" pitchFamily="34" charset="-120"/>
               </a:rPr>
-              <a:t>ui-wireframes.md</a:t>
+              <a:t>uml-pack.md</a:t>
             </a:r>
             <a:endParaRPr lang="en-US" sz="1100" dirty="0"/>
           </a:p>
@@ -14412,7 +14429,7 @@
                 <a:ea typeface="Calibri" pitchFamily="34" charset="-122"/>
                 <a:cs typeface="Calibri" pitchFamily="34" charset="-120"/>
               </a:rPr>
-              <a:t>✓  画 ASCII 流程图</a:t>
+              <a:t>✓  画 Mermaid 流程图</a:t>
             </a:r>
             <a:endParaRPr lang="en-US" sz="1000" dirty="0"/>
           </a:p>

</xml_diff>

<commit_message>
feat: 新增 assets/ 运营资产骨架（configs/interfaces/standards/manuals + 角色边界说明）（v2.9.0）
</commit_message>
<xml_diff>
--- a/SSOT-开发方法论-培训.pptx
+++ b/SSOT-开发方法论-培训.pptx
@@ -6798,6 +6798,190 @@
       </p:sp>
       <p:sp>
         <p:nvSpPr>
+          <p:cNvPr id="18" name="Shape 16"/>
+          <p:cNvSpPr/>
+          <p:nvPr/>
+        </p:nvSpPr>
+        <p:spPr>
+          <a:xfrm>
+            <a:off x="1920240" y="3950208"/>
+            <a:ext cx="6858000" cy="658368"/>
+          </a:xfrm>
+          <a:prstGeom prst="rect">
+            <a:avLst/>
+          </a:prstGeom>
+          <a:solidFill>
+            <a:srgbClr val="F8FAFC"/>
+          </a:solidFill>
+          <a:ln/>
+          <a:effectLst>
+            <a:outerShdw sx="100000" sy="100000" kx="0" ky="0" algn="bl" rotWithShape="0" blurRad="50800" dist="25400" dir="8100000">
+              <a:srgbClr val="000000">
+                <a:alpha val="8000"/>
+              </a:srgbClr>
+            </a:outerShdw>
+          </a:effectLst>
+        </p:spPr>
+      </p:sp>
+      <p:sp>
+        <p:nvSpPr>
+          <p:cNvPr id="19" name="Shape 17"/>
+          <p:cNvSpPr/>
+          <p:nvPr/>
+        </p:nvSpPr>
+        <p:spPr>
+          <a:xfrm>
+            <a:off x="1920240" y="3950208"/>
+            <a:ext cx="54864" cy="658368"/>
+          </a:xfrm>
+          <a:prstGeom prst="rect">
+            <a:avLst/>
+          </a:prstGeom>
+          <a:solidFill>
+            <a:srgbClr val="14B8A6"/>
+          </a:solidFill>
+          <a:ln/>
+        </p:spPr>
+      </p:sp>
+      <p:sp>
+        <p:nvSpPr>
+          <p:cNvPr id="20" name="Shape 18"/>
+          <p:cNvSpPr/>
+          <p:nvPr/>
+        </p:nvSpPr>
+        <p:spPr>
+          <a:xfrm>
+            <a:off x="2057400" y="4041648"/>
+            <a:ext cx="502920" cy="365760"/>
+          </a:xfrm>
+          <a:prstGeom prst="rect">
+            <a:avLst/>
+          </a:prstGeom>
+          <a:solidFill>
+            <a:srgbClr val="14B8A6"/>
+          </a:solidFill>
+          <a:ln/>
+        </p:spPr>
+      </p:sp>
+      <p:sp>
+        <p:nvSpPr>
+          <p:cNvPr id="21" name="Text 19"/>
+          <p:cNvSpPr/>
+          <p:nvPr/>
+        </p:nvSpPr>
+        <p:spPr>
+          <a:xfrm>
+            <a:off x="2057400" y="4041648"/>
+            <a:ext cx="502920" cy="365760"/>
+          </a:xfrm>
+          <a:prstGeom prst="rect">
+            <a:avLst/>
+          </a:prstGeom>
+          <a:noFill/>
+          <a:ln/>
+        </p:spPr>
+        <p:txBody>
+          <a:bodyPr wrap="square" lIns="0" tIns="0" rIns="0" bIns="0" rtlCol="0" anchor="ctr"/>
+          <a:lstStyle/>
+          <a:p>
+            <a:pPr algn="ctr" indent="0" marL="0">
+              <a:buNone/>
+            </a:pPr>
+            <a:r>
+              <a:rPr lang="en-US" sz="1000" b="1" dirty="0">
+                <a:solidFill>
+                  <a:srgbClr val="FFFFFF"/>
+                </a:solidFill>
+                <a:latin typeface="Calibri" pitchFamily="34" charset="0"/>
+                <a:ea typeface="Calibri" pitchFamily="34" charset="-122"/>
+                <a:cs typeface="Calibri" pitchFamily="34" charset="-120"/>
+              </a:rPr>
+              <a:t>Ops</a:t>
+            </a:r>
+            <a:endParaRPr lang="en-US" sz="1000" dirty="0"/>
+          </a:p>
+        </p:txBody>
+      </p:sp>
+      <p:sp>
+        <p:nvSpPr>
+          <p:cNvPr id="22" name="Text 20"/>
+          <p:cNvSpPr/>
+          <p:nvPr/>
+        </p:nvSpPr>
+        <p:spPr>
+          <a:xfrm>
+            <a:off x="2697480" y="4041648"/>
+            <a:ext cx="2286000" cy="365760"/>
+          </a:xfrm>
+          <a:prstGeom prst="rect">
+            <a:avLst/>
+          </a:prstGeom>
+          <a:noFill/>
+          <a:ln/>
+        </p:spPr>
+        <p:txBody>
+          <a:bodyPr wrap="square" lIns="0" tIns="0" rIns="0" bIns="0" rtlCol="0" anchor="ctr"/>
+          <a:lstStyle/>
+          <a:p>
+            <a:pPr indent="0" marL="0">
+              <a:buNone/>
+            </a:pPr>
+            <a:r>
+              <a:rPr lang="en-US" sz="1000" dirty="0">
+                <a:solidFill>
+                  <a:srgbClr val="1E293B"/>
+                </a:solidFill>
+                <a:latin typeface="Calibri" pitchFamily="34" charset="0"/>
+                <a:ea typeface="Calibri" pitchFamily="34" charset="-122"/>
+                <a:cs typeface="Calibri" pitchFamily="34" charset="-120"/>
+              </a:rPr>
+              <a:t>assets/</a:t>
+            </a:r>
+            <a:endParaRPr lang="en-US" sz="1000" dirty="0"/>
+          </a:p>
+        </p:txBody>
+      </p:sp>
+      <p:sp>
+        <p:nvSpPr>
+          <p:cNvPr id="23" name="Text 21"/>
+          <p:cNvSpPr/>
+          <p:nvPr/>
+        </p:nvSpPr>
+        <p:spPr>
+          <a:xfrm>
+            <a:off x="5074920" y="4041648"/>
+            <a:ext cx="3566160" cy="457200"/>
+          </a:xfrm>
+          <a:prstGeom prst="rect">
+            <a:avLst/>
+          </a:prstGeom>
+          <a:noFill/>
+          <a:ln/>
+        </p:spPr>
+        <p:txBody>
+          <a:bodyPr wrap="square" lIns="0" tIns="0" rIns="0" bIns="0" rtlCol="0" anchor="ctr"/>
+          <a:lstStyle/>
+          <a:p>
+            <a:pPr indent="0" marL="0">
+              <a:buNone/>
+            </a:pPr>
+            <a:r>
+              <a:rPr lang="en-US" sz="900" dirty="0">
+                <a:solidFill>
+                  <a:srgbClr val="64748B"/>
+                </a:solidFill>
+                <a:latin typeface="Calibri" pitchFamily="34" charset="0"/>
+                <a:ea typeface="Calibri" pitchFamily="34" charset="-122"/>
+                <a:cs typeface="Calibri" pitchFamily="34" charset="-120"/>
+              </a:rPr>
+              <a:t>部署 / 配置 / 接口 / 手册</a:t>
+            </a:r>
+            <a:endParaRPr lang="en-US" sz="900" dirty="0"/>
+          </a:p>
+        </p:txBody>
+      </p:sp>
+      <p:sp>
+        <p:nvSpPr>
           <p:cNvPr id="30" name="Shape 28"/>
           <p:cNvSpPr/>
           <p:nvPr/>
@@ -11286,6 +11470,190 @@
                 <a:cs typeface="Calibri" pitchFamily="34" charset="-120"/>
               </a:rPr>
               <a:t>AI 协作入口</a:t>
+            </a:r>
+            <a:endParaRPr lang="en-US" sz="1000" dirty="0"/>
+          </a:p>
+        </p:txBody>
+      </p:sp>
+      <p:sp>
+        <p:nvSpPr>
+          <p:cNvPr id="18" name="Shape 16"/>
+          <p:cNvSpPr/>
+          <p:nvPr/>
+        </p:nvSpPr>
+        <p:spPr>
+          <a:xfrm>
+            <a:off x="1920240" y="3950208"/>
+            <a:ext cx="6858000" cy="658368"/>
+          </a:xfrm>
+          <a:prstGeom prst="rect">
+            <a:avLst/>
+          </a:prstGeom>
+          <a:solidFill>
+            <a:srgbClr val="F8FAFC"/>
+          </a:solidFill>
+          <a:ln/>
+          <a:effectLst>
+            <a:outerShdw sx="100000" sy="100000" kx="0" ky="0" algn="bl" rotWithShape="0" blurRad="50800" dist="25400" dir="8100000">
+              <a:srgbClr val="000000">
+                <a:alpha val="8000"/>
+              </a:srgbClr>
+            </a:outerShdw>
+          </a:effectLst>
+        </p:spPr>
+      </p:sp>
+      <p:sp>
+        <p:nvSpPr>
+          <p:cNvPr id="19" name="Shape 17"/>
+          <p:cNvSpPr/>
+          <p:nvPr/>
+        </p:nvSpPr>
+        <p:spPr>
+          <a:xfrm>
+            <a:off x="1920240" y="3950208"/>
+            <a:ext cx="54864" cy="658368"/>
+          </a:xfrm>
+          <a:prstGeom prst="rect">
+            <a:avLst/>
+          </a:prstGeom>
+          <a:solidFill>
+            <a:srgbClr val="14B8A6"/>
+          </a:solidFill>
+          <a:ln/>
+        </p:spPr>
+      </p:sp>
+      <p:sp>
+        <p:nvSpPr>
+          <p:cNvPr id="20" name="Shape 18"/>
+          <p:cNvSpPr/>
+          <p:nvPr/>
+        </p:nvSpPr>
+        <p:spPr>
+          <a:xfrm>
+            <a:off x="2057400" y="4041648"/>
+            <a:ext cx="502920" cy="365760"/>
+          </a:xfrm>
+          <a:prstGeom prst="rect">
+            <a:avLst/>
+          </a:prstGeom>
+          <a:solidFill>
+            <a:srgbClr val="14B8A6"/>
+          </a:solidFill>
+          <a:ln/>
+        </p:spPr>
+      </p:sp>
+      <p:sp>
+        <p:nvSpPr>
+          <p:cNvPr id="21" name="Text 19"/>
+          <p:cNvSpPr/>
+          <p:nvPr/>
+        </p:nvSpPr>
+        <p:spPr>
+          <a:xfrm>
+            <a:off x="2057400" y="4041648"/>
+            <a:ext cx="502920" cy="365760"/>
+          </a:xfrm>
+          <a:prstGeom prst="rect">
+            <a:avLst/>
+          </a:prstGeom>
+          <a:noFill/>
+          <a:ln/>
+        </p:spPr>
+        <p:txBody>
+          <a:bodyPr wrap="square" lIns="0" tIns="0" rIns="0" bIns="0" rtlCol="0" anchor="ctr"/>
+          <a:lstStyle/>
+          <a:p>
+            <a:pPr algn="ctr" indent="0" marL="0">
+              <a:buNone/>
+            </a:pPr>
+            <a:r>
+              <a:rPr lang="en-US" sz="900" b="1" dirty="0">
+                <a:solidFill>
+                  <a:srgbClr val="FFFFFF"/>
+                </a:solidFill>
+                <a:latin typeface="Calibri" pitchFamily="34" charset="0"/>
+                <a:ea typeface="Calibri" pitchFamily="34" charset="-122"/>
+                <a:cs typeface="Calibri" pitchFamily="34" charset="-120"/>
+              </a:rPr>
+              <a:t>Ops</a:t>
+            </a:r>
+            <a:endParaRPr lang="en-US" sz="900" dirty="0"/>
+          </a:p>
+        </p:txBody>
+      </p:sp>
+      <p:sp>
+        <p:nvSpPr>
+          <p:cNvPr id="22" name="Text 20"/>
+          <p:cNvSpPr/>
+          <p:nvPr/>
+        </p:nvSpPr>
+        <p:spPr>
+          <a:xfrm>
+            <a:off x="2697480" y="4041648"/>
+            <a:ext cx="2286000" cy="365760"/>
+          </a:xfrm>
+          <a:prstGeom prst="rect">
+            <a:avLst/>
+          </a:prstGeom>
+          <a:noFill/>
+          <a:ln/>
+        </p:spPr>
+        <p:txBody>
+          <a:bodyPr wrap="square" lIns="0" tIns="0" rIns="0" bIns="0" rtlCol="0" anchor="ctr"/>
+          <a:lstStyle/>
+          <a:p>
+            <a:pPr indent="0" marL="0">
+              <a:buNone/>
+            </a:pPr>
+            <a:r>
+              <a:rPr lang="en-US" sz="1300" b="1" dirty="0">
+                <a:solidFill>
+                  <a:srgbClr val="1E293B"/>
+                </a:solidFill>
+                <a:latin typeface="Calibri" pitchFamily="34" charset="0"/>
+                <a:ea typeface="Calibri" pitchFamily="34" charset="-122"/>
+                <a:cs typeface="Calibri" pitchFamily="34" charset="-120"/>
+              </a:rPr>
+              <a:t>assets/</a:t>
+            </a:r>
+            <a:endParaRPr lang="en-US" sz="1300" dirty="0"/>
+          </a:p>
+        </p:txBody>
+      </p:sp>
+      <p:sp>
+        <p:nvSpPr>
+          <p:cNvPr id="23" name="Text 21"/>
+          <p:cNvSpPr/>
+          <p:nvPr/>
+        </p:nvSpPr>
+        <p:spPr>
+          <a:xfrm>
+            <a:off x="5074920" y="4041648"/>
+            <a:ext cx="3566160" cy="457200"/>
+          </a:xfrm>
+          <a:prstGeom prst="rect">
+            <a:avLst/>
+          </a:prstGeom>
+          <a:noFill/>
+          <a:ln/>
+        </p:spPr>
+        <p:txBody>
+          <a:bodyPr wrap="square" lIns="0" tIns="0" rIns="0" bIns="0" rtlCol="0" anchor="ctr"/>
+          <a:lstStyle/>
+          <a:p>
+            <a:pPr indent="0" marL="0">
+              <a:buNone/>
+            </a:pPr>
+            <a:r>
+              <a:rPr lang="en-US" sz="1000" dirty="0">
+                <a:solidFill>
+                  <a:srgbClr val="64748B"/>
+                </a:solidFill>
+                <a:latin typeface="Calibri" pitchFamily="34" charset="0"/>
+                <a:ea typeface="Calibri" pitchFamily="34" charset="-122"/>
+                <a:cs typeface="Calibri" pitchFamily="34" charset="-120"/>
+              </a:rPr>
+              <a:t>运营资产：配置 / 接口 / 规范 / 手册</a:t>
             </a:r>
             <a:endParaRPr lang="en-US" sz="1000" dirty="0"/>
           </a:p>

</xml_diff>

<commit_message>
feat: SpecRocket v3.0.0 结构升级 — sprints 顶层迭代容器(含 docs+specs) / adrs / 规格归迭代 / 白皮书
- sprints/sp-NNN-名称/ 迭代容器：docs/(PM 产品设计) + specs/(Dev 技术规格，多 spec 共同促成一次迭代)
- adrs/adr-NNN-名称 全局架构决策（不随 sprint 走）
- apps/businesses/tools 回归纯代码域（删 specs/）
- docs/ 新增 whitepaper.md
- 命名全小写连字符：sp-/spec-/adr-
- 规格拆分原则：解耦 + 提升 token 利用率，不刻意多拆
- migrate v3.0：转移→收敛→保留→删除，零残留
- 四文件同步：SKILL/AGENTS/CLAUDE/README 中英 + PPT 16 处更新
</commit_message>
<xml_diff>
--- a/SSOT-开发方法论-培训.pptx
+++ b/SSOT-开发方法论-培训.pptx
@@ -2229,6 +2229,10 @@
           </a:solidFill>
           <a:ln/>
         </p:spPr>
+        <p:txBody>
+          <a:bodyPr/>
+          <a:p/>
+        </p:txBody>
       </p:sp>
       <p:sp>
         <p:nvSpPr>
@@ -2251,6 +2255,10 @@
           </a:solidFill>
           <a:ln/>
         </p:spPr>
+        <p:txBody>
+          <a:bodyPr/>
+          <a:p/>
+        </p:txBody>
       </p:sp>
       <p:sp>
         <p:nvSpPr>
@@ -2427,6 +2435,10 @@
           </a:solidFill>
           <a:ln/>
         </p:spPr>
+        <p:txBody>
+          <a:bodyPr/>
+          <a:p/>
+        </p:txBody>
       </p:sp>
       <p:sp>
         <p:nvSpPr>
@@ -2518,6 +2530,10 @@
           </a:solidFill>
           <a:ln/>
         </p:spPr>
+        <p:txBody>
+          <a:bodyPr/>
+          <a:p/>
+        </p:txBody>
       </p:sp>
       <p:sp>
         <p:nvSpPr>
@@ -2633,6 +2649,10 @@
           </a:solidFill>
           <a:ln/>
         </p:spPr>
+        <p:txBody>
+          <a:bodyPr/>
+          <a:p/>
+        </p:txBody>
       </p:sp>
       <p:sp>
         <p:nvSpPr>
@@ -2699,6 +2719,10 @@
             </a:outerShdw>
           </a:effectLst>
         </p:spPr>
+        <p:txBody>
+          <a:bodyPr/>
+          <a:p/>
+        </p:txBody>
       </p:sp>
       <p:sp>
         <p:nvSpPr>
@@ -2719,6 +2743,10 @@
           </a:solidFill>
           <a:ln/>
         </p:spPr>
+        <p:txBody>
+          <a:bodyPr/>
+          <a:p/>
+        </p:txBody>
       </p:sp>
       <p:sp>
         <p:nvSpPr>
@@ -2847,6 +2875,10 @@
             </a:outerShdw>
           </a:effectLst>
         </p:spPr>
+        <p:txBody>
+          <a:bodyPr/>
+          <a:p/>
+        </p:txBody>
       </p:sp>
       <p:sp>
         <p:nvSpPr>
@@ -2867,6 +2899,10 @@
           </a:solidFill>
           <a:ln/>
         </p:spPr>
+        <p:txBody>
+          <a:bodyPr/>
+          <a:p/>
+        </p:txBody>
       </p:sp>
       <p:sp>
         <p:nvSpPr>
@@ -2989,6 +3025,10 @@
             </a:outerShdw>
           </a:effectLst>
         </p:spPr>
+        <p:txBody>
+          <a:bodyPr/>
+          <a:p/>
+        </p:txBody>
       </p:sp>
       <p:sp>
         <p:nvSpPr>
@@ -3104,6 +3144,10 @@
           </a:solidFill>
           <a:ln/>
         </p:spPr>
+        <p:txBody>
+          <a:bodyPr/>
+          <a:p/>
+        </p:txBody>
       </p:sp>
       <p:sp>
         <p:nvSpPr>
@@ -3195,6 +3239,10 @@
           </a:solidFill>
           <a:ln/>
         </p:spPr>
+        <p:txBody>
+          <a:bodyPr/>
+          <a:p/>
+        </p:txBody>
       </p:sp>
       <p:sp>
         <p:nvSpPr>
@@ -3310,6 +3358,10 @@
           </a:solidFill>
           <a:ln/>
         </p:spPr>
+        <p:txBody>
+          <a:bodyPr/>
+          <a:p/>
+        </p:txBody>
       </p:sp>
       <p:sp>
         <p:nvSpPr>
@@ -3376,6 +3428,10 @@
             </a:outerShdw>
           </a:effectLst>
         </p:spPr>
+        <p:txBody>
+          <a:bodyPr/>
+          <a:p/>
+        </p:txBody>
       </p:sp>
       <p:sp>
         <p:nvSpPr>
@@ -3396,6 +3452,10 @@
           </a:solidFill>
           <a:ln/>
         </p:spPr>
+        <p:txBody>
+          <a:bodyPr/>
+          <a:p/>
+        </p:txBody>
       </p:sp>
       <p:sp>
         <p:nvSpPr>
@@ -3557,6 +3617,10 @@
             </a:outerShdw>
           </a:effectLst>
         </p:spPr>
+        <p:txBody>
+          <a:bodyPr/>
+          <a:p/>
+        </p:txBody>
       </p:sp>
       <p:sp>
         <p:nvSpPr>
@@ -3577,6 +3641,10 @@
           </a:solidFill>
           <a:ln/>
         </p:spPr>
+        <p:txBody>
+          <a:bodyPr/>
+          <a:p/>
+        </p:txBody>
       </p:sp>
       <p:sp>
         <p:nvSpPr>
@@ -3738,6 +3806,10 @@
             </a:outerShdw>
           </a:effectLst>
         </p:spPr>
+        <p:txBody>
+          <a:bodyPr/>
+          <a:p/>
+        </p:txBody>
       </p:sp>
       <p:sp>
         <p:nvSpPr>
@@ -3758,6 +3830,10 @@
           </a:solidFill>
           <a:ln/>
         </p:spPr>
+        <p:txBody>
+          <a:bodyPr/>
+          <a:p/>
+        </p:txBody>
       </p:sp>
       <p:sp>
         <p:nvSpPr>
@@ -3919,6 +3995,10 @@
             </a:outerShdw>
           </a:effectLst>
         </p:spPr>
+        <p:txBody>
+          <a:bodyPr/>
+          <a:p/>
+        </p:txBody>
       </p:sp>
       <p:sp>
         <p:nvSpPr>
@@ -3939,6 +4019,10 @@
           </a:solidFill>
           <a:ln/>
         </p:spPr>
+        <p:txBody>
+          <a:bodyPr/>
+          <a:p/>
+        </p:txBody>
       </p:sp>
       <p:sp>
         <p:nvSpPr>
@@ -4100,6 +4184,10 @@
             </a:outerShdw>
           </a:effectLst>
         </p:spPr>
+        <p:txBody>
+          <a:bodyPr/>
+          <a:p/>
+        </p:txBody>
       </p:sp>
       <p:sp>
         <p:nvSpPr>
@@ -4120,6 +4208,10 @@
           </a:solidFill>
           <a:ln/>
         </p:spPr>
+        <p:txBody>
+          <a:bodyPr/>
+          <a:p/>
+        </p:txBody>
       </p:sp>
       <p:sp>
         <p:nvSpPr>
@@ -4242,6 +4334,10 @@
             </a:outerShdw>
           </a:effectLst>
         </p:spPr>
+        <p:txBody>
+          <a:bodyPr/>
+          <a:p/>
+        </p:txBody>
       </p:sp>
       <p:sp>
         <p:nvSpPr>
@@ -4262,6 +4358,10 @@
           </a:solidFill>
           <a:ln/>
         </p:spPr>
+        <p:txBody>
+          <a:bodyPr/>
+          <a:p/>
+        </p:txBody>
       </p:sp>
       <p:sp>
         <p:nvSpPr>
@@ -4411,6 +4511,10 @@
           </a:solidFill>
           <a:ln/>
         </p:spPr>
+        <p:txBody>
+          <a:bodyPr/>
+          <a:p/>
+        </p:txBody>
       </p:sp>
       <p:sp>
         <p:nvSpPr>
@@ -4502,6 +4606,10 @@
           </a:solidFill>
           <a:ln/>
         </p:spPr>
+        <p:txBody>
+          <a:bodyPr/>
+          <a:p/>
+        </p:txBody>
       </p:sp>
       <p:sp>
         <p:nvSpPr>
@@ -4617,6 +4725,10 @@
           </a:solidFill>
           <a:ln/>
         </p:spPr>
+        <p:txBody>
+          <a:bodyPr/>
+          <a:p/>
+        </p:txBody>
       </p:sp>
       <p:sp>
         <p:nvSpPr>
@@ -5772,6 +5884,10 @@
           </a:solidFill>
           <a:ln/>
         </p:spPr>
+        <p:txBody>
+          <a:bodyPr/>
+          <a:p/>
+        </p:txBody>
       </p:sp>
       <p:sp>
         <p:nvSpPr>
@@ -5870,6 +5986,10 @@
           </a:solidFill>
           <a:ln/>
         </p:spPr>
+        <p:txBody>
+          <a:bodyPr/>
+          <a:p/>
+        </p:txBody>
       </p:sp>
       <p:sp>
         <p:nvSpPr>
@@ -5961,6 +6081,10 @@
           </a:solidFill>
           <a:ln/>
         </p:spPr>
+        <p:txBody>
+          <a:bodyPr/>
+          <a:p/>
+        </p:txBody>
       </p:sp>
       <p:sp>
         <p:nvSpPr>
@@ -6059,6 +6183,10 @@
           </a:solidFill>
           <a:ln/>
         </p:spPr>
+        <p:txBody>
+          <a:bodyPr/>
+          <a:p/>
+        </p:txBody>
       </p:sp>
       <p:sp>
         <p:nvSpPr>
@@ -6086,6 +6214,10 @@
             </a:outerShdw>
           </a:effectLst>
         </p:spPr>
+        <p:txBody>
+          <a:bodyPr/>
+          <a:p/>
+        </p:txBody>
       </p:sp>
       <p:sp>
         <p:nvSpPr>
@@ -6106,6 +6238,10 @@
           </a:solidFill>
           <a:ln/>
         </p:spPr>
+        <p:txBody>
+          <a:bodyPr/>
+          <a:p/>
+        </p:txBody>
       </p:sp>
       <p:sp>
         <p:nvSpPr>
@@ -6126,6 +6262,10 @@
           </a:solidFill>
           <a:ln/>
         </p:spPr>
+        <p:txBody>
+          <a:bodyPr/>
+          <a:p/>
+        </p:txBody>
       </p:sp>
       <p:sp>
         <p:nvSpPr>
@@ -6270,6 +6410,10 @@
             </a:outerShdw>
           </a:effectLst>
         </p:spPr>
+        <p:txBody>
+          <a:bodyPr/>
+          <a:p/>
+        </p:txBody>
       </p:sp>
       <p:sp>
         <p:nvSpPr>
@@ -6290,6 +6434,10 @@
           </a:solidFill>
           <a:ln/>
         </p:spPr>
+        <p:txBody>
+          <a:bodyPr/>
+          <a:p/>
+        </p:txBody>
       </p:sp>
       <p:sp>
         <p:nvSpPr>
@@ -6310,6 +6458,10 @@
           </a:solidFill>
           <a:ln/>
         </p:spPr>
+        <p:txBody>
+          <a:bodyPr/>
+          <a:p/>
+        </p:txBody>
       </p:sp>
       <p:sp>
         <p:nvSpPr>
@@ -6383,7 +6535,7 @@
                 <a:ea typeface="Calibri" pitchFamily="34" charset="-122"/>
                 <a:cs typeface="Calibri" pitchFamily="34" charset="-120"/>
               </a:rPr>
-              <a:t>ADR/ + 审 spec + 修边界 bug</a:t>
+              <a:t>adrs/ + 审 spec + 修边界 bug</a:t>
             </a:r>
             <a:endParaRPr lang="en-US" sz="1000" dirty="0"/>
           </a:p>
@@ -6454,6 +6606,10 @@
             </a:outerShdw>
           </a:effectLst>
         </p:spPr>
+        <p:txBody>
+          <a:bodyPr/>
+          <a:p/>
+        </p:txBody>
       </p:sp>
       <p:sp>
         <p:nvSpPr>
@@ -6474,6 +6630,10 @@
           </a:solidFill>
           <a:ln/>
         </p:spPr>
+        <p:txBody>
+          <a:bodyPr/>
+          <a:p/>
+        </p:txBody>
       </p:sp>
       <p:sp>
         <p:nvSpPr>
@@ -6494,6 +6654,10 @@
           </a:solidFill>
           <a:ln/>
         </p:spPr>
+        <p:txBody>
+          <a:bodyPr/>
+          <a:p/>
+        </p:txBody>
       </p:sp>
       <p:sp>
         <p:nvSpPr>
@@ -6567,7 +6731,7 @@
                 <a:ea typeface="Calibri" pitchFamily="34" charset="-122"/>
                 <a:cs typeface="Calibri" pitchFamily="34" charset="-120"/>
               </a:rPr>
-              <a:t>specs/ 四文件 + 按 spec 编码 + 自检</a:t>
+              <a:t>sprints/*/sprints/*/specs/ 四文件 + 按 spec 编码 + 自检</a:t>
             </a:r>
             <a:endParaRPr lang="en-US" sz="1000" dirty="0"/>
           </a:p>
@@ -6638,6 +6802,10 @@
             </a:outerShdw>
           </a:effectLst>
         </p:spPr>
+        <p:txBody>
+          <a:bodyPr/>
+          <a:p/>
+        </p:txBody>
       </p:sp>
       <p:sp>
         <p:nvSpPr>
@@ -6658,6 +6826,10 @@
           </a:solidFill>
           <a:ln/>
         </p:spPr>
+        <p:txBody>
+          <a:bodyPr/>
+          <a:p/>
+        </p:txBody>
       </p:sp>
       <p:sp>
         <p:nvSpPr>
@@ -6678,6 +6850,10 @@
           </a:solidFill>
           <a:ln/>
         </p:spPr>
+        <p:txBody>
+          <a:bodyPr/>
+          <a:p/>
+        </p:txBody>
       </p:sp>
       <p:sp>
         <p:nvSpPr>
@@ -6822,6 +6998,10 @@
             </a:outerShdw>
           </a:effectLst>
         </p:spPr>
+        <p:txBody>
+          <a:bodyPr/>
+          <a:p/>
+        </p:txBody>
       </p:sp>
       <p:sp>
         <p:nvSpPr>
@@ -6842,6 +7022,10 @@
           </a:solidFill>
           <a:ln/>
         </p:spPr>
+        <p:txBody>
+          <a:bodyPr/>
+          <a:p/>
+        </p:txBody>
       </p:sp>
       <p:sp>
         <p:nvSpPr>
@@ -6862,6 +7046,10 @@
           </a:solidFill>
           <a:ln/>
         </p:spPr>
+        <p:txBody>
+          <a:bodyPr/>
+          <a:p/>
+        </p:txBody>
       </p:sp>
       <p:sp>
         <p:nvSpPr>
@@ -6999,6 +7187,10 @@
           </a:solidFill>
           <a:ln/>
         </p:spPr>
+        <p:txBody>
+          <a:bodyPr/>
+          <a:p/>
+        </p:txBody>
       </p:sp>
       <p:sp>
         <p:nvSpPr>
@@ -7090,6 +7282,10 @@
           </a:solidFill>
           <a:ln/>
         </p:spPr>
+        <p:txBody>
+          <a:bodyPr/>
+          <a:p/>
+        </p:txBody>
       </p:sp>
       <p:sp>
         <p:nvSpPr>
@@ -7188,6 +7384,10 @@
           </a:solidFill>
           <a:ln/>
         </p:spPr>
+        <p:txBody>
+          <a:bodyPr/>
+          <a:p/>
+        </p:txBody>
       </p:sp>
       <p:sp>
         <p:nvSpPr>
@@ -7215,6 +7415,10 @@
             </a:outerShdw>
           </a:effectLst>
         </p:spPr>
+        <p:txBody>
+          <a:bodyPr/>
+          <a:p/>
+        </p:txBody>
       </p:sp>
       <p:sp>
         <p:nvSpPr>
@@ -7235,6 +7439,10 @@
           </a:solidFill>
           <a:ln/>
         </p:spPr>
+        <p:txBody>
+          <a:bodyPr/>
+          <a:p/>
+        </p:txBody>
       </p:sp>
       <p:sp>
         <p:nvSpPr>
@@ -7340,6 +7548,10 @@
             </a:outerShdw>
           </a:effectLst>
         </p:spPr>
+        <p:txBody>
+          <a:bodyPr/>
+          <a:p/>
+        </p:txBody>
       </p:sp>
       <p:sp>
         <p:nvSpPr>
@@ -7360,6 +7572,10 @@
           </a:solidFill>
           <a:ln/>
         </p:spPr>
+        <p:txBody>
+          <a:bodyPr/>
+          <a:p/>
+        </p:txBody>
       </p:sp>
       <p:sp>
         <p:nvSpPr>
@@ -7465,6 +7681,10 @@
             </a:outerShdw>
           </a:effectLst>
         </p:spPr>
+        <p:txBody>
+          <a:bodyPr/>
+          <a:p/>
+        </p:txBody>
       </p:sp>
       <p:sp>
         <p:nvSpPr>
@@ -7485,6 +7705,10 @@
           </a:solidFill>
           <a:ln/>
         </p:spPr>
+        <p:txBody>
+          <a:bodyPr/>
+          <a:p/>
+        </p:txBody>
       </p:sp>
       <p:sp>
         <p:nvSpPr>
@@ -7590,6 +7814,10 @@
             </a:outerShdw>
           </a:effectLst>
         </p:spPr>
+        <p:txBody>
+          <a:bodyPr/>
+          <a:p/>
+        </p:txBody>
       </p:sp>
       <p:sp>
         <p:nvSpPr>
@@ -7610,6 +7838,10 @@
           </a:solidFill>
           <a:ln/>
         </p:spPr>
+        <p:txBody>
+          <a:bodyPr/>
+          <a:p/>
+        </p:txBody>
       </p:sp>
       <p:sp>
         <p:nvSpPr>
@@ -7708,6 +7940,10 @@
           </a:solidFill>
           <a:ln/>
         </p:spPr>
+        <p:txBody>
+          <a:bodyPr/>
+          <a:p/>
+        </p:txBody>
       </p:sp>
       <p:sp>
         <p:nvSpPr>
@@ -7799,6 +8035,10 @@
           </a:solidFill>
           <a:ln/>
         </p:spPr>
+        <p:txBody>
+          <a:bodyPr/>
+          <a:p/>
+        </p:txBody>
       </p:sp>
       <p:sp>
         <p:nvSpPr>
@@ -7897,6 +8137,10 @@
           </a:solidFill>
           <a:ln/>
         </p:spPr>
+        <p:txBody>
+          <a:bodyPr/>
+          <a:p/>
+        </p:txBody>
       </p:sp>
       <p:sp>
         <p:nvSpPr>
@@ -7931,7 +8175,7 @@
                 <a:ea typeface="Calibri" pitchFamily="34" charset="-122"/>
                 <a:cs typeface="Calibri" pitchFamily="34" charset="-120"/>
               </a:rPr>
-              <a:t>当 app 引用 business 的 specs 时，使用 Context Contract（≤15 行）</a:t>
+              <a:t>当 spec 依赖其他 spec 时，使用 Context Contract（≤15 行）</a:t>
             </a:r>
             <a:endParaRPr lang="en-US" sz="1100" dirty="0"/>
           </a:p>
@@ -7963,6 +8207,10 @@
             </a:outerShdw>
           </a:effectLst>
         </p:spPr>
+        <p:txBody>
+          <a:bodyPr/>
+          <a:p/>
+        </p:txBody>
       </p:sp>
       <p:sp>
         <p:nvSpPr>
@@ -7983,6 +8231,10 @@
           </a:solidFill>
           <a:ln/>
         </p:spPr>
+        <p:txBody>
+          <a:bodyPr/>
+          <a:p/>
+        </p:txBody>
       </p:sp>
       <p:sp>
         <p:nvSpPr>
@@ -8079,7 +8331,7 @@
                 <a:ea typeface="Calibri" pitchFamily="34" charset="-122"/>
                 <a:cs typeface="Calibri" pitchFamily="34" charset="-120"/>
               </a:rPr>
-              <a:t>### BIZ-001 (user-service)</a:t>
+              <a:t>### spec-002 (后端认证服务)</a:t>
             </a:r>
             <a:endParaRPr lang="en-US" sz="900" dirty="0"/>
           </a:p>
@@ -8145,6 +8397,10 @@
             </a:outerShdw>
           </a:effectLst>
         </p:spPr>
+        <p:txBody>
+          <a:bodyPr/>
+          <a:p/>
+        </p:txBody>
       </p:sp>
       <p:sp>
         <p:nvSpPr>
@@ -8165,6 +8421,10 @@
           </a:solidFill>
           <a:ln/>
         </p:spPr>
+        <p:txBody>
+          <a:bodyPr/>
+          <a:p/>
+        </p:txBody>
       </p:sp>
       <p:sp>
         <p:nvSpPr>
@@ -8354,6 +8614,10 @@
           </a:solidFill>
           <a:ln/>
         </p:spPr>
+        <p:txBody>
+          <a:bodyPr/>
+          <a:p/>
+        </p:txBody>
       </p:sp>
       <p:sp>
         <p:nvSpPr>
@@ -8445,6 +8709,10 @@
           </a:solidFill>
           <a:ln/>
         </p:spPr>
+        <p:txBody>
+          <a:bodyPr/>
+          <a:p/>
+        </p:txBody>
       </p:sp>
       <p:sp>
         <p:nvSpPr>
@@ -8582,6 +8850,10 @@
           </a:solidFill>
           <a:ln/>
         </p:spPr>
+        <p:txBody>
+          <a:bodyPr/>
+          <a:p/>
+        </p:txBody>
       </p:sp>
       <p:sp>
         <p:nvSpPr>
@@ -8680,6 +8952,10 @@
           </a:solidFill>
           <a:ln/>
         </p:spPr>
+        <p:txBody>
+          <a:bodyPr/>
+          <a:p/>
+        </p:txBody>
       </p:sp>
       <p:sp>
         <p:nvSpPr>
@@ -8778,6 +9054,10 @@
           </a:solidFill>
           <a:ln/>
         </p:spPr>
+        <p:txBody>
+          <a:bodyPr/>
+          <a:p/>
+        </p:txBody>
       </p:sp>
       <p:sp>
         <p:nvSpPr>
@@ -8876,6 +9156,10 @@
           </a:solidFill>
           <a:ln/>
         </p:spPr>
+        <p:txBody>
+          <a:bodyPr/>
+          <a:p/>
+        </p:txBody>
       </p:sp>
       <p:sp>
         <p:nvSpPr>
@@ -8974,6 +9258,10 @@
           </a:solidFill>
           <a:ln/>
         </p:spPr>
+        <p:txBody>
+          <a:bodyPr/>
+          <a:p/>
+        </p:txBody>
       </p:sp>
       <p:sp>
         <p:nvSpPr>
@@ -9072,6 +9360,10 @@
           </a:solidFill>
           <a:ln/>
         </p:spPr>
+        <p:txBody>
+          <a:bodyPr/>
+          <a:p/>
+        </p:txBody>
       </p:sp>
       <p:sp>
         <p:nvSpPr>
@@ -9163,6 +9455,10 @@
           </a:solidFill>
           <a:ln/>
         </p:spPr>
+        <p:txBody>
+          <a:bodyPr/>
+          <a:p/>
+        </p:txBody>
       </p:sp>
       <p:sp>
         <p:nvSpPr>
@@ -9261,6 +9557,10 @@
           </a:solidFill>
           <a:ln/>
         </p:spPr>
+        <p:txBody>
+          <a:bodyPr/>
+          <a:p/>
+        </p:txBody>
       </p:sp>
       <p:sp>
         <p:nvSpPr>
@@ -9288,6 +9588,10 @@
             </a:outerShdw>
           </a:effectLst>
         </p:spPr>
+        <p:txBody>
+          <a:bodyPr/>
+          <a:p/>
+        </p:txBody>
       </p:sp>
       <p:sp>
         <p:nvSpPr>
@@ -9308,6 +9612,10 @@
           </a:solidFill>
           <a:ln/>
         </p:spPr>
+        <p:txBody>
+          <a:bodyPr/>
+          <a:p/>
+        </p:txBody>
       </p:sp>
       <p:sp>
         <p:nvSpPr>
@@ -9413,6 +9721,10 @@
             </a:outerShdw>
           </a:effectLst>
         </p:spPr>
+        <p:txBody>
+          <a:bodyPr/>
+          <a:p/>
+        </p:txBody>
       </p:sp>
       <p:sp>
         <p:nvSpPr>
@@ -9433,6 +9745,10 @@
           </a:solidFill>
           <a:ln/>
         </p:spPr>
+        <p:txBody>
+          <a:bodyPr/>
+          <a:p/>
+        </p:txBody>
       </p:sp>
       <p:sp>
         <p:nvSpPr>
@@ -9538,6 +9854,10 @@
             </a:outerShdw>
           </a:effectLst>
         </p:spPr>
+        <p:txBody>
+          <a:bodyPr/>
+          <a:p/>
+        </p:txBody>
       </p:sp>
       <p:sp>
         <p:nvSpPr>
@@ -9558,6 +9878,10 @@
           </a:solidFill>
           <a:ln/>
         </p:spPr>
+        <p:txBody>
+          <a:bodyPr/>
+          <a:p/>
+        </p:txBody>
       </p:sp>
       <p:sp>
         <p:nvSpPr>
@@ -9663,6 +9987,10 @@
             </a:outerShdw>
           </a:effectLst>
         </p:spPr>
+        <p:txBody>
+          <a:bodyPr/>
+          <a:p/>
+        </p:txBody>
       </p:sp>
       <p:sp>
         <p:nvSpPr>
@@ -9683,6 +10011,10 @@
           </a:solidFill>
           <a:ln/>
         </p:spPr>
+        <p:txBody>
+          <a:bodyPr/>
+          <a:p/>
+        </p:txBody>
       </p:sp>
       <p:sp>
         <p:nvSpPr>
@@ -9781,6 +10113,10 @@
           </a:solidFill>
           <a:ln/>
         </p:spPr>
+        <p:txBody>
+          <a:bodyPr/>
+          <a:p/>
+        </p:txBody>
       </p:sp>
       <p:sp>
         <p:nvSpPr>
@@ -9840,6 +10176,10 @@
           </a:solidFill>
           <a:ln/>
         </p:spPr>
+        <p:txBody>
+          <a:bodyPr/>
+          <a:p/>
+        </p:txBody>
       </p:sp>
       <p:sp>
         <p:nvSpPr>
@@ -9931,6 +10271,10 @@
           </a:solidFill>
           <a:ln/>
         </p:spPr>
+        <p:txBody>
+          <a:bodyPr/>
+          <a:p/>
+        </p:txBody>
       </p:sp>
       <p:sp>
         <p:nvSpPr>
@@ -10029,6 +10373,10 @@
           </a:solidFill>
           <a:ln/>
         </p:spPr>
+        <p:txBody>
+          <a:bodyPr/>
+          <a:p/>
+        </p:txBody>
       </p:sp>
       <p:sp>
         <p:nvSpPr>
@@ -10056,6 +10404,10 @@
             </a:outerShdw>
           </a:effectLst>
         </p:spPr>
+        <p:txBody>
+          <a:bodyPr/>
+          <a:p/>
+        </p:txBody>
       </p:sp>
       <p:sp>
         <p:nvSpPr>
@@ -10076,6 +10428,10 @@
           </a:solidFill>
           <a:ln/>
         </p:spPr>
+        <p:txBody>
+          <a:bodyPr/>
+          <a:p/>
+        </p:txBody>
       </p:sp>
       <p:sp>
         <p:nvSpPr>
@@ -10181,6 +10537,10 @@
             </a:outerShdw>
           </a:effectLst>
         </p:spPr>
+        <p:txBody>
+          <a:bodyPr/>
+          <a:p/>
+        </p:txBody>
       </p:sp>
       <p:sp>
         <p:nvSpPr>
@@ -10201,6 +10561,10 @@
           </a:solidFill>
           <a:ln/>
         </p:spPr>
+        <p:txBody>
+          <a:bodyPr/>
+          <a:p/>
+        </p:txBody>
       </p:sp>
       <p:sp>
         <p:nvSpPr>
@@ -10306,6 +10670,10 @@
             </a:outerShdw>
           </a:effectLst>
         </p:spPr>
+        <p:txBody>
+          <a:bodyPr/>
+          <a:p/>
+        </p:txBody>
       </p:sp>
       <p:sp>
         <p:nvSpPr>
@@ -10326,6 +10694,10 @@
           </a:solidFill>
           <a:ln/>
         </p:spPr>
+        <p:txBody>
+          <a:bodyPr/>
+          <a:p/>
+        </p:txBody>
       </p:sp>
       <p:sp>
         <p:nvSpPr>
@@ -10431,6 +10803,10 @@
             </a:outerShdw>
           </a:effectLst>
         </p:spPr>
+        <p:txBody>
+          <a:bodyPr/>
+          <a:p/>
+        </p:txBody>
       </p:sp>
       <p:sp>
         <p:nvSpPr>
@@ -10451,6 +10827,10 @@
           </a:solidFill>
           <a:ln/>
         </p:spPr>
+        <p:txBody>
+          <a:bodyPr/>
+          <a:p/>
+        </p:txBody>
       </p:sp>
       <p:sp>
         <p:nvSpPr>
@@ -10549,6 +10929,10 @@
           </a:solidFill>
           <a:ln/>
         </p:spPr>
+        <p:txBody>
+          <a:bodyPr/>
+          <a:p/>
+        </p:txBody>
       </p:sp>
       <p:sp>
         <p:nvSpPr>
@@ -10640,6 +11024,10 @@
           </a:solidFill>
           <a:ln/>
         </p:spPr>
+        <p:txBody>
+          <a:bodyPr/>
+          <a:p/>
+        </p:txBody>
       </p:sp>
       <p:sp>
         <p:nvSpPr>
@@ -10738,6 +11126,10 @@
           </a:solidFill>
           <a:ln/>
         </p:spPr>
+        <p:txBody>
+          <a:bodyPr/>
+          <a:p/>
+        </p:txBody>
       </p:sp>
       <p:sp>
         <p:nvSpPr>
@@ -10765,6 +11157,10 @@
             </a:outerShdw>
           </a:effectLst>
         </p:spPr>
+        <p:txBody>
+          <a:bodyPr/>
+          <a:p/>
+        </p:txBody>
       </p:sp>
       <p:sp>
         <p:nvSpPr>
@@ -10785,6 +11181,10 @@
           </a:solidFill>
           <a:ln/>
         </p:spPr>
+        <p:txBody>
+          <a:bodyPr/>
+          <a:p/>
+        </p:txBody>
       </p:sp>
       <p:sp>
         <p:nvSpPr>
@@ -10805,6 +11205,10 @@
           </a:solidFill>
           <a:ln/>
         </p:spPr>
+        <p:txBody>
+          <a:bodyPr/>
+          <a:p/>
+        </p:txBody>
       </p:sp>
       <p:sp>
         <p:nvSpPr>
@@ -10949,6 +11353,10 @@
             </a:outerShdw>
           </a:effectLst>
         </p:spPr>
+        <p:txBody>
+          <a:bodyPr/>
+          <a:p/>
+        </p:txBody>
       </p:sp>
       <p:sp>
         <p:nvSpPr>
@@ -10969,6 +11377,10 @@
           </a:solidFill>
           <a:ln/>
         </p:spPr>
+        <p:txBody>
+          <a:bodyPr/>
+          <a:p/>
+        </p:txBody>
       </p:sp>
       <p:sp>
         <p:nvSpPr>
@@ -10989,6 +11401,10 @@
           </a:solidFill>
           <a:ln/>
         </p:spPr>
+        <p:txBody>
+          <a:bodyPr/>
+          <a:p/>
+        </p:txBody>
       </p:sp>
       <p:sp>
         <p:nvSpPr>
@@ -11101,7 +11517,7 @@
                 <a:ea typeface="Calibri" pitchFamily="34" charset="-122"/>
                 <a:cs typeface="Calibri" pitchFamily="34" charset="-120"/>
               </a:rPr>
-              <a:t>代码 + specs/ 四文件</a:t>
+              <a:t>纯代码域 src/（规格在迭代容器）</a:t>
             </a:r>
             <a:endParaRPr lang="en-US" sz="1000" dirty="0"/>
           </a:p>
@@ -11133,6 +11549,10 @@
             </a:outerShdw>
           </a:effectLst>
         </p:spPr>
+        <p:txBody>
+          <a:bodyPr/>
+          <a:p/>
+        </p:txBody>
       </p:sp>
       <p:sp>
         <p:nvSpPr>
@@ -11153,6 +11573,10 @@
           </a:solidFill>
           <a:ln/>
         </p:spPr>
+        <p:txBody>
+          <a:bodyPr/>
+          <a:p/>
+        </p:txBody>
       </p:sp>
       <p:sp>
         <p:nvSpPr>
@@ -11173,6 +11597,10 @@
           </a:solidFill>
           <a:ln/>
         </p:spPr>
+        <p:txBody>
+          <a:bodyPr/>
+          <a:p/>
+        </p:txBody>
       </p:sp>
       <p:sp>
         <p:nvSpPr>
@@ -11246,7 +11674,7 @@
                 <a:ea typeface="Calibri" pitchFamily="34" charset="-122"/>
                 <a:cs typeface="Calibri" pitchFamily="34" charset="-120"/>
               </a:rPr>
-              <a:t>ADR/</a:t>
+              <a:t>adrs/</a:t>
             </a:r>
             <a:endParaRPr lang="en-US" sz="1300" dirty="0"/>
           </a:p>
@@ -11285,7 +11713,7 @@
                 <a:ea typeface="Calibri" pitchFamily="34" charset="-122"/>
                 <a:cs typeface="Calibri" pitchFamily="34" charset="-120"/>
               </a:rPr>
-              <a:t>架构决策 + 数据字典</a:t>
+              <a:t>架构决策（全局历史累积）</a:t>
             </a:r>
             <a:endParaRPr lang="en-US" sz="1000" dirty="0"/>
           </a:p>
@@ -11317,6 +11745,10 @@
             </a:outerShdw>
           </a:effectLst>
         </p:spPr>
+        <p:txBody>
+          <a:bodyPr/>
+          <a:p/>
+        </p:txBody>
       </p:sp>
       <p:sp>
         <p:nvSpPr>
@@ -11337,6 +11769,10 @@
           </a:solidFill>
           <a:ln/>
         </p:spPr>
+        <p:txBody>
+          <a:bodyPr/>
+          <a:p/>
+        </p:txBody>
       </p:sp>
       <p:sp>
         <p:nvSpPr>
@@ -11357,6 +11793,10 @@
           </a:solidFill>
           <a:ln/>
         </p:spPr>
+        <p:txBody>
+          <a:bodyPr/>
+          <a:p/>
+        </p:txBody>
       </p:sp>
       <p:sp>
         <p:nvSpPr>
@@ -11501,6 +11941,10 @@
             </a:outerShdw>
           </a:effectLst>
         </p:spPr>
+        <p:txBody>
+          <a:bodyPr/>
+          <a:p/>
+        </p:txBody>
       </p:sp>
       <p:sp>
         <p:nvSpPr>
@@ -11521,6 +11965,10 @@
           </a:solidFill>
           <a:ln/>
         </p:spPr>
+        <p:txBody>
+          <a:bodyPr/>
+          <a:p/>
+        </p:txBody>
       </p:sp>
       <p:sp>
         <p:nvSpPr>
@@ -11541,6 +11989,10 @@
           </a:solidFill>
           <a:ln/>
         </p:spPr>
+        <p:txBody>
+          <a:bodyPr/>
+          <a:p/>
+        </p:txBody>
       </p:sp>
       <p:sp>
         <p:nvSpPr>
@@ -11678,6 +12130,10 @@
           </a:solidFill>
           <a:ln/>
         </p:spPr>
+        <p:txBody>
+          <a:bodyPr/>
+          <a:p/>
+        </p:txBody>
       </p:sp>
       <p:sp>
         <p:nvSpPr>
@@ -11769,6 +12225,10 @@
           </a:solidFill>
           <a:ln/>
         </p:spPr>
+        <p:txBody>
+          <a:bodyPr/>
+          <a:p/>
+        </p:txBody>
       </p:sp>
       <p:sp>
         <p:nvSpPr>
@@ -11867,6 +12327,10 @@
           </a:solidFill>
           <a:ln/>
         </p:spPr>
+        <p:txBody>
+          <a:bodyPr/>
+          <a:p/>
+        </p:txBody>
       </p:sp>
       <p:sp>
         <p:nvSpPr>
@@ -11894,6 +12358,10 @@
             </a:outerShdw>
           </a:effectLst>
         </p:spPr>
+        <p:txBody>
+          <a:bodyPr/>
+          <a:p/>
+        </p:txBody>
       </p:sp>
       <p:sp>
         <p:nvSpPr>
@@ -11914,6 +12382,10 @@
           </a:solidFill>
           <a:ln/>
         </p:spPr>
+        <p:txBody>
+          <a:bodyPr/>
+          <a:p/>
+        </p:txBody>
       </p:sp>
       <p:sp>
         <p:nvSpPr>
@@ -12116,6 +12588,10 @@
             </a:outerShdw>
           </a:effectLst>
         </p:spPr>
+        <p:txBody>
+          <a:bodyPr/>
+          <a:p/>
+        </p:txBody>
       </p:sp>
       <p:sp>
         <p:nvSpPr>
@@ -12136,6 +12612,10 @@
           </a:solidFill>
           <a:ln/>
         </p:spPr>
+        <p:txBody>
+          <a:bodyPr/>
+          <a:p/>
+        </p:txBody>
       </p:sp>
       <p:sp>
         <p:nvSpPr>
@@ -12209,7 +12689,7 @@
                 <a:ea typeface="Calibri" pitchFamily="34" charset="-122"/>
                 <a:cs typeface="Calibri" pitchFamily="34" charset="-120"/>
               </a:rPr>
-              <a:t>sprint-NNN_name/</a:t>
+              <a:t>sp-NNN-名称/（docs/ + specs/）</a:t>
             </a:r>
             <a:endParaRPr lang="en-US" sz="1100" dirty="0"/>
           </a:p>
@@ -12342,6 +12822,10 @@
           </a:solidFill>
           <a:ln/>
         </p:spPr>
+        <p:txBody>
+          <a:bodyPr/>
+          <a:p/>
+        </p:txBody>
       </p:sp>
       <p:sp>
         <p:nvSpPr>
@@ -12433,6 +12917,10 @@
           </a:solidFill>
           <a:ln/>
         </p:spPr>
+        <p:txBody>
+          <a:bodyPr/>
+          <a:p/>
+        </p:txBody>
       </p:sp>
       <p:sp>
         <p:nvSpPr>
@@ -12531,6 +13019,10 @@
           </a:solidFill>
           <a:ln/>
         </p:spPr>
+        <p:txBody>
+          <a:bodyPr/>
+          <a:p/>
+        </p:txBody>
       </p:sp>
       <p:sp>
         <p:nvSpPr>
@@ -12558,6 +13050,10 @@
             </a:outerShdw>
           </a:effectLst>
         </p:spPr>
+        <p:txBody>
+          <a:bodyPr/>
+          <a:p/>
+        </p:txBody>
       </p:sp>
       <p:sp>
         <p:nvSpPr>
@@ -12578,6 +13074,10 @@
           </a:solidFill>
           <a:ln/>
         </p:spPr>
+        <p:txBody>
+          <a:bodyPr/>
+          <a:p/>
+        </p:txBody>
       </p:sp>
       <p:sp>
         <p:nvSpPr>
@@ -12612,7 +13112,7 @@
                 <a:ea typeface="Calibri" pitchFamily="34" charset="-122"/>
                 <a:cs typeface="Calibri" pitchFamily="34" charset="-120"/>
               </a:rPr>
-              <a:t>specs/ 四文件</a:t>
+              <a:t>sprints/*/specs/ 四文件</a:t>
             </a:r>
             <a:endParaRPr lang="en-US" sz="1300" dirty="0"/>
           </a:p>
@@ -12637,6 +13137,10 @@
           </a:solidFill>
           <a:ln/>
         </p:spPr>
+        <p:txBody>
+          <a:bodyPr/>
+          <a:p/>
+        </p:txBody>
       </p:sp>
       <p:sp>
         <p:nvSpPr>
@@ -12735,6 +13239,10 @@
           </a:solidFill>
           <a:ln/>
         </p:spPr>
+        <p:txBody>
+          <a:bodyPr/>
+          <a:p/>
+        </p:txBody>
       </p:sp>
       <p:sp>
         <p:nvSpPr>
@@ -12833,6 +13341,10 @@
           </a:solidFill>
           <a:ln/>
         </p:spPr>
+        <p:txBody>
+          <a:bodyPr/>
+          <a:p/>
+        </p:txBody>
       </p:sp>
       <p:sp>
         <p:nvSpPr>
@@ -12931,6 +13443,10 @@
           </a:solidFill>
           <a:ln/>
         </p:spPr>
+        <p:txBody>
+          <a:bodyPr/>
+          <a:p/>
+        </p:txBody>
       </p:sp>
       <p:sp>
         <p:nvSpPr>
@@ -13036,6 +13552,10 @@
             </a:outerShdw>
           </a:effectLst>
         </p:spPr>
+        <p:txBody>
+          <a:bodyPr/>
+          <a:p/>
+        </p:txBody>
       </p:sp>
       <p:sp>
         <p:nvSpPr>
@@ -13056,6 +13576,10 @@
           </a:solidFill>
           <a:ln/>
         </p:spPr>
+        <p:txBody>
+          <a:bodyPr/>
+          <a:p/>
+        </p:txBody>
       </p:sp>
       <p:sp>
         <p:nvSpPr>
@@ -13090,7 +13614,7 @@
                 <a:ea typeface="Calibri" pitchFamily="34" charset="-122"/>
                 <a:cs typeface="Calibri" pitchFamily="34" charset="-120"/>
               </a:rPr>
-              <a:t>ADR/ 架构文档库</a:t>
+              <a:t>adrs/ 架构文档库</a:t>
             </a:r>
             <a:endParaRPr lang="en-US" sz="1300" dirty="0"/>
           </a:p>
@@ -13272,7 +13796,7 @@
                 <a:ea typeface="Calibri" pitchFamily="34" charset="-122"/>
                 <a:cs typeface="Calibri" pitchFamily="34" charset="-120"/>
               </a:rPr>
-              <a:t>新人先读 ADR/，30 分钟看懂系统</a:t>
+              <a:t>新人先读 adrs/，30 分钟看懂系统</a:t>
             </a:r>
             <a:endParaRPr lang="en-US" sz="1000" dirty="0"/>
           </a:p>
@@ -13297,6 +13821,10 @@
           </a:solidFill>
           <a:ln/>
         </p:spPr>
+        <p:txBody>
+          <a:bodyPr/>
+          <a:p/>
+        </p:txBody>
       </p:sp>
       <p:sp>
         <p:nvSpPr>
@@ -13388,6 +13916,10 @@
           </a:solidFill>
           <a:ln/>
         </p:spPr>
+        <p:txBody>
+          <a:bodyPr/>
+          <a:p/>
+        </p:txBody>
       </p:sp>
       <p:sp>
         <p:nvSpPr>
@@ -13486,6 +14018,10 @@
           </a:solidFill>
           <a:ln/>
         </p:spPr>
+        <p:txBody>
+          <a:bodyPr/>
+          <a:p/>
+        </p:txBody>
       </p:sp>
       <p:sp>
         <p:nvSpPr>
@@ -13506,6 +14042,10 @@
           </a:solidFill>
           <a:ln/>
         </p:spPr>
+        <p:txBody>
+          <a:bodyPr/>
+          <a:p/>
+        </p:txBody>
       </p:sp>
       <p:sp>
         <p:nvSpPr>
@@ -13682,6 +14222,10 @@
           </a:solidFill>
           <a:ln/>
         </p:spPr>
+        <p:txBody>
+          <a:bodyPr/>
+          <a:p/>
+        </p:txBody>
       </p:sp>
       <p:sp>
         <p:nvSpPr>
@@ -13794,7 +14338,7 @@
                 <a:ea typeface="Calibri" pitchFamily="34" charset="-122"/>
                 <a:cs typeface="Calibri" pitchFamily="34" charset="-120"/>
               </a:rPr>
-              <a:t>ADR/ + specs/</a:t>
+              <a:t>adrs/ + sprints/*/specs/</a:t>
             </a:r>
             <a:endParaRPr lang="en-US" sz="900" dirty="0"/>
           </a:p>
@@ -13858,6 +14402,10 @@
           </a:solidFill>
           <a:ln/>
         </p:spPr>
+        <p:txBody>
+          <a:bodyPr/>
+          <a:p/>
+        </p:txBody>
       </p:sp>
       <p:sp>
         <p:nvSpPr>
@@ -14034,6 +14582,10 @@
           </a:solidFill>
           <a:ln/>
         </p:spPr>
+        <p:txBody>
+          <a:bodyPr/>
+          <a:p/>
+        </p:txBody>
       </p:sp>
       <p:sp>
         <p:nvSpPr>
@@ -14210,6 +14762,10 @@
           </a:solidFill>
           <a:ln/>
         </p:spPr>
+        <p:txBody>
+          <a:bodyPr/>
+          <a:p/>
+        </p:txBody>
       </p:sp>
       <p:sp>
         <p:nvSpPr>
@@ -14347,6 +14903,10 @@
           </a:solidFill>
           <a:ln/>
         </p:spPr>
+        <p:txBody>
+          <a:bodyPr/>
+          <a:p/>
+        </p:txBody>
       </p:sp>
       <p:sp>
         <p:nvSpPr>
@@ -14506,6 +15066,10 @@
           </a:solidFill>
           <a:ln/>
         </p:spPr>
+        <p:txBody>
+          <a:bodyPr/>
+          <a:p/>
+        </p:txBody>
       </p:sp>
       <p:sp>
         <p:nvSpPr>
@@ -14621,6 +15185,10 @@
           </a:solidFill>
           <a:ln/>
         </p:spPr>
+        <p:txBody>
+          <a:bodyPr/>
+          <a:p/>
+        </p:txBody>
       </p:sp>
       <p:sp>
         <p:nvSpPr>
@@ -14687,6 +15255,10 @@
             </a:outerShdw>
           </a:effectLst>
         </p:spPr>
+        <p:txBody>
+          <a:bodyPr/>
+          <a:p/>
+        </p:txBody>
       </p:sp>
       <p:sp>
         <p:nvSpPr>
@@ -14707,6 +15279,10 @@
           </a:solidFill>
           <a:ln/>
         </p:spPr>
+        <p:txBody>
+          <a:bodyPr/>
+          <a:p/>
+        </p:txBody>
       </p:sp>
       <p:sp>
         <p:nvSpPr>
@@ -14880,6 +15456,10 @@
             </a:outerShdw>
           </a:effectLst>
         </p:spPr>
+        <p:txBody>
+          <a:bodyPr/>
+          <a:p/>
+        </p:txBody>
       </p:sp>
       <p:sp>
         <p:nvSpPr>
@@ -14900,6 +15480,10 @@
           </a:solidFill>
           <a:ln/>
         </p:spPr>
+        <p:txBody>
+          <a:bodyPr/>
+          <a:p/>
+        </p:txBody>
       </p:sp>
       <p:sp>
         <p:nvSpPr>
@@ -15056,6 +15640,10 @@
             </a:outerShdw>
           </a:effectLst>
         </p:spPr>
+        <p:txBody>
+          <a:bodyPr/>
+          <a:p/>
+        </p:txBody>
       </p:sp>
       <p:sp>
         <p:nvSpPr>
@@ -15154,6 +15742,10 @@
           </a:solidFill>
           <a:ln/>
         </p:spPr>
+        <p:txBody>
+          <a:bodyPr/>
+          <a:p/>
+        </p:txBody>
       </p:sp>
       <p:sp>
         <p:nvSpPr>
@@ -15245,6 +15837,10 @@
           </a:solidFill>
           <a:ln/>
         </p:spPr>
+        <p:txBody>
+          <a:bodyPr/>
+          <a:p/>
+        </p:txBody>
       </p:sp>
       <p:sp>
         <p:nvSpPr>
@@ -15360,6 +15956,10 @@
           </a:solidFill>
           <a:ln/>
         </p:spPr>
+        <p:txBody>
+          <a:bodyPr/>
+          <a:p/>
+        </p:txBody>
       </p:sp>
       <p:sp>
         <p:nvSpPr>
@@ -15426,6 +16026,10 @@
             </a:outerShdw>
           </a:effectLst>
         </p:spPr>
+        <p:txBody>
+          <a:bodyPr/>
+          <a:p/>
+        </p:txBody>
       </p:sp>
       <p:sp>
         <p:nvSpPr>
@@ -15446,6 +16050,10 @@
           </a:solidFill>
           <a:ln/>
         </p:spPr>
+        <p:txBody>
+          <a:bodyPr/>
+          <a:p/>
+        </p:txBody>
       </p:sp>
       <p:sp>
         <p:nvSpPr>
@@ -15519,7 +16127,7 @@
                 <a:ea typeface="Calibri" pitchFamily="34" charset="-122"/>
                 <a:cs typeface="Calibri" pitchFamily="34" charset="-120"/>
               </a:rPr>
-              <a:t>① 功能归属哪个模块？</a:t>
+              <a:t>① 本次迭代拆几个 spec？</a:t>
             </a:r>
             <a:endParaRPr lang="en-US" sz="1000" dirty="0"/>
           </a:p>
@@ -15536,7 +16144,7 @@
                 <a:ea typeface="Calibri" pitchFamily="34" charset="-122"/>
                 <a:cs typeface="Calibri" pitchFamily="34" charset="-120"/>
               </a:rPr>
-              <a:t>② 需要新 ADR 吗？</a:t>
+              <a:t>② 需要新 adr 吗？</a:t>
             </a:r>
             <a:endParaRPr lang="en-US" sz="1000" dirty="0"/>
           </a:p>
@@ -15553,7 +16161,7 @@
                 <a:ea typeface="Calibri" pitchFamily="34" charset="-122"/>
                 <a:cs typeface="Calibri" pitchFamily="34" charset="-120"/>
               </a:rPr>
-              <a:t>③ 跨模块依赖？</a:t>
+              <a:t>③ 跨 spec 依赖？</a:t>
             </a:r>
             <a:endParaRPr lang="en-US" sz="1000" dirty="0"/>
           </a:p>
@@ -15602,6 +16210,10 @@
             </a:outerShdw>
           </a:effectLst>
         </p:spPr>
+        <p:txBody>
+          <a:bodyPr/>
+          <a:p/>
+        </p:txBody>
       </p:sp>
       <p:sp>
         <p:nvSpPr>
@@ -15622,6 +16234,10 @@
           </a:solidFill>
           <a:ln/>
         </p:spPr>
+        <p:txBody>
+          <a:bodyPr/>
+          <a:p/>
+        </p:txBody>
       </p:sp>
       <p:sp>
         <p:nvSpPr>
@@ -15695,7 +16311,7 @@
                 <a:ea typeface="Calibri" pitchFamily="34" charset="-122"/>
                 <a:cs typeface="Calibri" pitchFamily="34" charset="-120"/>
               </a:rPr>
-              <a:t>→ ADR/ 架构文档</a:t>
+              <a:t>→ adrs/ 架构文档 + 迭代 specs/ 四文件</a:t>
             </a:r>
             <a:endParaRPr lang="en-US" sz="1000" dirty="0"/>
           </a:p>
@@ -15788,6 +16404,10 @@
           </a:solidFill>
           <a:ln/>
         </p:spPr>
+        <p:txBody>
+          <a:bodyPr/>
+          <a:p/>
+        </p:txBody>
       </p:sp>
       <p:sp>
         <p:nvSpPr>

</xml_diff>